<commit_message>
Simplify slide decks and remove repeated content
Remove divider subtitles that repeat the agenda, make diagrams the
focus on two slides, drop a repeated Ch04 slide, and declutter
Chapters 01, 06, and 07.

Co-authored-by: Copilot <223556219+Copilot@users.noreply.github.com>
</commit_message>
<xml_diff>
--- a/slides/00-setup.pptx
+++ b/slides/00-setup.pptx
@@ -2591,7 +2591,7 @@
         </p:nvSpPr>
         <p:spPr>
           <a:xfrm>
-            <a:off x="711101" y="1571774"/>
+            <a:off x="711101" y="1937534"/>
             <a:ext cx="5570169" cy="209550"/>
           </a:xfrm>
           <a:prstGeom prst="rect">
@@ -2630,7 +2630,7 @@
         </p:nvSpPr>
         <p:spPr>
           <a:xfrm>
-            <a:off x="711101" y="1882825"/>
+            <a:off x="711101" y="2248585"/>
             <a:ext cx="5570169" cy="584150"/>
           </a:xfrm>
           <a:prstGeom prst="rect">
@@ -2675,7 +2675,7 @@
         </p:nvSpPr>
         <p:spPr>
           <a:xfrm>
-            <a:off x="711101" y="2670125"/>
+            <a:off x="711101" y="3035885"/>
             <a:ext cx="609600" cy="63401"/>
           </a:xfrm>
           <a:prstGeom prst="roundRect">
@@ -2696,48 +2696,6 @@
               <a:buNone/>
             </a:pPr>
             <a:endParaRPr lang="en-US" dirty="0"/>
-          </a:p>
-        </p:txBody>
-      </p:sp>
-      <p:sp>
-        <p:nvSpPr>
-          <p:cNvPr id="12" name="Text 8"/>
-          <p:cNvSpPr/>
-          <p:nvPr/>
-        </p:nvSpPr>
-        <p:spPr>
-          <a:xfrm>
-            <a:off x="711101" y="2936677"/>
-            <a:ext cx="5570169" cy="634901"/>
-          </a:xfrm>
-          <a:prstGeom prst="rect">
-            <a:avLst/>
-          </a:prstGeom>
-          <a:noFill/>
-          <a:ln/>
-        </p:spPr>
-        <p:txBody>
-          <a:bodyPr wrap="square" lIns="0" tIns="0" rIns="0" bIns="0" rtlCol="0" anchor="t"/>
-          <a:lstStyle/>
-          <a:p>
-            <a:pPr algn="l" indent="0" marL="0">
-              <a:lnSpc>
-                <a:spcPts val="2500"/>
-              </a:lnSpc>
-              <a:buNone/>
-            </a:pPr>
-            <a:r>
-              <a:rPr lang="en-US" sz="1900" dirty="0">
-                <a:solidFill>
-                  <a:srgbClr val="59636E"/>
-                </a:solidFill>
-                <a:latin typeface="Arial" pitchFamily="34" charset="0"/>
-                <a:ea typeface="Arial" pitchFamily="34" charset="-122"/>
-                <a:cs typeface="Arial" pitchFamily="34" charset="-120"/>
-              </a:rPr>
-              <a:t>Check your tools, then seed your fork with the practice work for later chapters.</a:t>
-            </a:r>
-            <a:endParaRPr lang="en-US" sz="1900" dirty="0"/>
           </a:p>
         </p:txBody>
       </p:sp>
@@ -10703,7 +10661,7 @@
         </p:nvSpPr>
         <p:spPr>
           <a:xfrm>
-            <a:off x="711101" y="1571774"/>
+            <a:off x="711101" y="1937534"/>
             <a:ext cx="5570169" cy="209550"/>
           </a:xfrm>
           <a:prstGeom prst="rect">
@@ -10742,7 +10700,7 @@
         </p:nvSpPr>
         <p:spPr>
           <a:xfrm>
-            <a:off x="711101" y="1882825"/>
+            <a:off x="711101" y="2248585"/>
             <a:ext cx="5570169" cy="584150"/>
           </a:xfrm>
           <a:prstGeom prst="rect">
@@ -10787,7 +10745,7 @@
         </p:nvSpPr>
         <p:spPr>
           <a:xfrm>
-            <a:off x="711101" y="2670125"/>
+            <a:off x="711101" y="3035885"/>
             <a:ext cx="609600" cy="63401"/>
           </a:xfrm>
           <a:prstGeom prst="roundRect">
@@ -10808,48 +10766,6 @@
               <a:buNone/>
             </a:pPr>
             <a:endParaRPr lang="en-US" dirty="0"/>
-          </a:p>
-        </p:txBody>
-      </p:sp>
-      <p:sp>
-        <p:nvSpPr>
-          <p:cNvPr id="12" name="Text 8"/>
-          <p:cNvSpPr/>
-          <p:nvPr/>
-        </p:nvSpPr>
-        <p:spPr>
-          <a:xfrm>
-            <a:off x="711101" y="2936677"/>
-            <a:ext cx="5570169" cy="634901"/>
-          </a:xfrm>
-          <a:prstGeom prst="rect">
-            <a:avLst/>
-          </a:prstGeom>
-          <a:noFill/>
-          <a:ln/>
-        </p:spPr>
-        <p:txBody>
-          <a:bodyPr wrap="square" lIns="0" tIns="0" rIns="0" bIns="0" rtlCol="0" anchor="t"/>
-          <a:lstStyle/>
-          <a:p>
-            <a:pPr algn="l" indent="0" marL="0">
-              <a:lnSpc>
-                <a:spcPts val="2500"/>
-              </a:lnSpc>
-              <a:buNone/>
-            </a:pPr>
-            <a:r>
-              <a:rPr lang="en-US" sz="1900" dirty="0">
-                <a:solidFill>
-                  <a:srgbClr val="59636E"/>
-                </a:solidFill>
-                <a:latin typeface="Arial" pitchFamily="34" charset="0"/>
-                <a:ea typeface="Arial" pitchFamily="34" charset="-122"/>
-                <a:cs typeface="Arial" pitchFamily="34" charset="-120"/>
-              </a:rPr>
-              <a:t>Download the desktop app and sign in with your GitHub account.</a:t>
-            </a:r>
-            <a:endParaRPr lang="en-US" sz="1900" dirty="0"/>
           </a:p>
         </p:txBody>
       </p:sp>
@@ -11999,7 +11915,7 @@
         </p:nvSpPr>
         <p:spPr>
           <a:xfrm>
-            <a:off x="711101" y="1279773"/>
+            <a:off x="711101" y="1645533"/>
             <a:ext cx="5570169" cy="209550"/>
           </a:xfrm>
           <a:prstGeom prst="rect">
@@ -12038,7 +11954,7 @@
         </p:nvSpPr>
         <p:spPr>
           <a:xfrm>
-            <a:off x="711101" y="1590824"/>
+            <a:off x="711101" y="1956584"/>
             <a:ext cx="5570169" cy="1168301"/>
           </a:xfrm>
           <a:prstGeom prst="rect">
@@ -12083,7 +11999,7 @@
         </p:nvSpPr>
         <p:spPr>
           <a:xfrm>
-            <a:off x="711101" y="2962275"/>
+            <a:off x="711101" y="3328035"/>
             <a:ext cx="609600" cy="63401"/>
           </a:xfrm>
           <a:prstGeom prst="roundRect">
@@ -12104,48 +12020,6 @@
               <a:buNone/>
             </a:pPr>
             <a:endParaRPr lang="en-US" dirty="0"/>
-          </a:p>
-        </p:txBody>
-      </p:sp>
-      <p:sp>
-        <p:nvSpPr>
-          <p:cNvPr id="12" name="Text 8"/>
-          <p:cNvSpPr/>
-          <p:nvPr/>
-        </p:nvSpPr>
-        <p:spPr>
-          <a:xfrm>
-            <a:off x="711101" y="3228826"/>
-            <a:ext cx="5570169" cy="634901"/>
-          </a:xfrm>
-          <a:prstGeom prst="rect">
-            <a:avLst/>
-          </a:prstGeom>
-          <a:noFill/>
-          <a:ln/>
-        </p:spPr>
-        <p:txBody>
-          <a:bodyPr wrap="square" lIns="0" tIns="0" rIns="0" bIns="0" rtlCol="0" anchor="t"/>
-          <a:lstStyle/>
-          <a:p>
-            <a:pPr algn="l" indent="0" marL="0">
-              <a:lnSpc>
-                <a:spcPts val="2500"/>
-              </a:lnSpc>
-              <a:buNone/>
-            </a:pPr>
-            <a:r>
-              <a:rPr lang="en-US" sz="1900" dirty="0">
-                <a:solidFill>
-                  <a:srgbClr val="59636E"/>
-                </a:solidFill>
-                <a:latin typeface="Arial" pitchFamily="34" charset="0"/>
-                <a:ea typeface="Arial" pitchFamily="34" charset="-122"/>
-                <a:cs typeface="Arial" pitchFamily="34" charset="-120"/>
-              </a:rPr>
-              <a:t>Fork the course, add it to the app as a project, and start your first project session.</a:t>
-            </a:r>
-            <a:endParaRPr lang="en-US" sz="1900" dirty="0"/>
           </a:p>
         </p:txBody>
       </p:sp>

</xml_diff>

<commit_message>
Improve slide visuals and screenshot clarity
Review all 124 slides and correct 17 slides across seven decks.
Remove repeated diagram labels, enlarge useful UI details, and retain
the shared design, course exercises, and speaker notes.

Co-authored-by: Copilot <223556219+Copilot@users.noreply.github.com>
</commit_message>
<xml_diff>
--- a/slides/00-setup.pptx
+++ b/slides/00-setup.pptx
@@ -12886,8 +12886,8 @@
         </ns0:nvSpPr>
         <ns0:spPr>
           <ns1:xfrm>
-            <ns1:off x="4320927" y="1579811"/>
-            <ns1:ext cx="4311551" cy="3037731"/>
+            <ns1:off x="4325112" y="2295144"/>
+            <ns1:ext cx="4306824" cy="1581963"/>
           </ns1:xfrm>
           <ns1:prstGeom prst="roundRect">
             <ns1:avLst>
@@ -12923,22 +12923,22 @@
       </ns0:sp>
       <ns0:pic>
         <ns0:nvPicPr>
-          <ns0:cNvPr id="22" name="Image 2" descr="Sessions menu with callouts for + and Add GitHub repository"/>
+          <ns0:cNvPr id="22" name="Image 2" descr="Sessions plus button and the complete menu, with Add GitHub repository highlighted. Callouts 1 and 2 remain visible."/>
           <ns0:cNvPicPr>
             <ns1:picLocks noChangeAspect="1"/>
           </ns0:cNvPicPr>
           <ns0:nvPr/>
         </ns0:nvPicPr>
         <ns0:blipFill>
-          <ns1:blip ns3:embed="rId4"/>
+          <ns1:blip ns3:embed="rId7"/>
           <ns1:stretch>
             <ns1:fillRect/>
           </ns1:stretch>
         </ns0:blipFill>
         <ns0:spPr>
           <ns1:xfrm>
-            <ns1:off x="4368552" y="1627436"/>
-            <ns1:ext cx="4216301" cy="2942481"/>
+            <ns1:off x="4370832" y="2340864"/>
+            <ns1:ext cx="4215384" cy="1490523"/>
           </ns1:xfrm>
           <ns1:prstGeom prst="rect">
             <ns1:avLst/>

</xml_diff>